<commit_message>
fix(eks): support permitted worker instances and EKS Pod Identity
</commit_message>
<xml_diff>
--- a/demo/presentation.pptx
+++ b/demo/presentation.pptx
@@ -2,23 +2,23 @@
 <file path=ppt/presentation.xml><?xml version="1.0" encoding="utf-8"?>
 <p:presentation xmlns:p="http://schemas.openxmlformats.org/presentationml/2006/main">
   <p:sldMasterIdLst>
-    <p:sldMasterId xmlns:r="http://schemas.openxmlformats.org/officeDocument/2006/relationships" id="2147483648" r:id="R7df9e90fd1a947a6"/>
+    <p:sldMasterId xmlns:r="http://schemas.openxmlformats.org/officeDocument/2006/relationships" id="2147483648" r:id="R1dd0ccffbcb24cbd"/>
   </p:sldMasterIdLst>
   <p:notesMasterIdLst>
-    <p:notesMasterId xmlns:r="http://schemas.openxmlformats.org/officeDocument/2006/relationships" r:id="R34c8fe55211c4c43"/>
+    <p:notesMasterId xmlns:r="http://schemas.openxmlformats.org/officeDocument/2006/relationships" r:id="R29e96cffcb3c45c7"/>
   </p:notesMasterIdLst>
   <p:sldIdLst>
-    <p:sldId xmlns:r="http://schemas.openxmlformats.org/officeDocument/2006/relationships" id="256" r:id="Refafcad4ade040bf"/>
-    <p:sldId xmlns:r="http://schemas.openxmlformats.org/officeDocument/2006/relationships" id="257" r:id="R5b8efddf09b84a40"/>
-    <p:sldId xmlns:r="http://schemas.openxmlformats.org/officeDocument/2006/relationships" id="258" r:id="R814374c8af5843ca"/>
-    <p:sldId xmlns:r="http://schemas.openxmlformats.org/officeDocument/2006/relationships" id="259" r:id="R0351e755517e40ea"/>
-    <p:sldId xmlns:r="http://schemas.openxmlformats.org/officeDocument/2006/relationships" id="260" r:id="R3649a023f35541c3"/>
-    <p:sldId xmlns:r="http://schemas.openxmlformats.org/officeDocument/2006/relationships" id="261" r:id="R8d91f97bfb284969"/>
-    <p:sldId xmlns:r="http://schemas.openxmlformats.org/officeDocument/2006/relationships" id="262" r:id="R761c7d0762914fa5"/>
-    <p:sldId xmlns:r="http://schemas.openxmlformats.org/officeDocument/2006/relationships" id="263" r:id="R11bfc4bab2eb4572"/>
-    <p:sldId xmlns:r="http://schemas.openxmlformats.org/officeDocument/2006/relationships" id="264" r:id="Rea0633d5f036415e"/>
-    <p:sldId xmlns:r="http://schemas.openxmlformats.org/officeDocument/2006/relationships" id="265" r:id="Rf1b2a1b738b843e8"/>
-    <p:sldId xmlns:r="http://schemas.openxmlformats.org/officeDocument/2006/relationships" id="266" r:id="R4a420659946642c3"/>
+    <p:sldId xmlns:r="http://schemas.openxmlformats.org/officeDocument/2006/relationships" id="256" r:id="R48f7003d0e394fa9"/>
+    <p:sldId xmlns:r="http://schemas.openxmlformats.org/officeDocument/2006/relationships" id="257" r:id="Re274b528415946d7"/>
+    <p:sldId xmlns:r="http://schemas.openxmlformats.org/officeDocument/2006/relationships" id="258" r:id="R4fbe1b8d09474f2e"/>
+    <p:sldId xmlns:r="http://schemas.openxmlformats.org/officeDocument/2006/relationships" id="259" r:id="Rf7b9d53f96f6498f"/>
+    <p:sldId xmlns:r="http://schemas.openxmlformats.org/officeDocument/2006/relationships" id="260" r:id="R7c990b2dbbfc43de"/>
+    <p:sldId xmlns:r="http://schemas.openxmlformats.org/officeDocument/2006/relationships" id="261" r:id="R2715ed68aefc4e09"/>
+    <p:sldId xmlns:r="http://schemas.openxmlformats.org/officeDocument/2006/relationships" id="262" r:id="R4e449cbee4a54336"/>
+    <p:sldId xmlns:r="http://schemas.openxmlformats.org/officeDocument/2006/relationships" id="263" r:id="Rb024112a0ebe4f2c"/>
+    <p:sldId xmlns:r="http://schemas.openxmlformats.org/officeDocument/2006/relationships" id="264" r:id="Rfb65a7f327214120"/>
+    <p:sldId xmlns:r="http://schemas.openxmlformats.org/officeDocument/2006/relationships" id="265" r:id="Rb2ba1c03b648445b"/>
+    <p:sldId xmlns:r="http://schemas.openxmlformats.org/officeDocument/2006/relationships" id="266" r:id="R152add34b18f437d"/>
   </p:sldIdLst>
   <p:sldSz cx="12192000" cy="6858000"/>
   <p:notesSz cx="6858000" cy="9144000"/>
@@ -1309,7 +1309,7 @@
           <p:cNvPr id="3" name="Title">
             <a:extLst xmlns:a="http://schemas.openxmlformats.org/drawingml/2006/main">
               <a:ext uri="{FF2B5EF4-FFF2-40B4-BE49-F238E27FC236}">
-                <a16:creationId xmlns:a16="http://schemas.microsoft.com/office/drawing/2014/main" id="{449E674F-9087-43EF-BC1B-60B7455D2723}"/>
+                <a16:creationId xmlns:a16="http://schemas.microsoft.com/office/drawing/2014/main" id="{A413FA95-858E-4F2F-9426-317134A43204}"/>
               </a:ext>
             </a:extLst>
           </p:cNvPr>
@@ -1466,7 +1466,7 @@
           <p:cNvPr id="2" name="Subtitle">
             <a:extLst xmlns:a="http://schemas.openxmlformats.org/drawingml/2006/main">
               <a:ext uri="{FF2B5EF4-FFF2-40B4-BE49-F238E27FC236}">
-                <a16:creationId xmlns:a16="http://schemas.microsoft.com/office/drawing/2014/main" id="{25C57736-1898-42A3-943E-BC4CD3A64E98}"/>
+                <a16:creationId xmlns:a16="http://schemas.microsoft.com/office/drawing/2014/main" id="{9FF1F6A1-46AC-411C-B560-319CD9376E16}"/>
               </a:ext>
             </a:extLst>
           </p:cNvPr>
@@ -1640,7 +1640,7 @@
           <p:cNvPr id="2" name="Section title">
             <a:extLst xmlns:a="http://schemas.openxmlformats.org/drawingml/2006/main">
               <a:ext uri="{FF2B5EF4-FFF2-40B4-BE49-F238E27FC236}">
-                <a16:creationId xmlns:a16="http://schemas.microsoft.com/office/drawing/2014/main" id="{F91EDCAF-02CF-40EE-9283-D318BCC87CF0}"/>
+                <a16:creationId xmlns:a16="http://schemas.microsoft.com/office/drawing/2014/main" id="{503E080B-6D3F-402F-9B54-AFB83C69B47F}"/>
               </a:ext>
             </a:extLst>
           </p:cNvPr>
@@ -1814,7 +1814,7 @@
           <p:cNvPr id="3" name="Title">
             <a:extLst xmlns:a="http://schemas.openxmlformats.org/drawingml/2006/main">
               <a:ext uri="{FF2B5EF4-FFF2-40B4-BE49-F238E27FC236}">
-                <a16:creationId xmlns:a16="http://schemas.microsoft.com/office/drawing/2014/main" id="{B1027FE8-388C-474D-ACE0-7C2C9436715B}"/>
+                <a16:creationId xmlns:a16="http://schemas.microsoft.com/office/drawing/2014/main" id="{2D09507A-1108-4378-9AF6-CD82EB400051}"/>
               </a:ext>
             </a:extLst>
           </p:cNvPr>
@@ -1971,7 +1971,7 @@
           <p:cNvPr id="2" name="Body">
             <a:extLst xmlns:a="http://schemas.openxmlformats.org/drawingml/2006/main">
               <a:ext uri="{FF2B5EF4-FFF2-40B4-BE49-F238E27FC236}">
-                <a16:creationId xmlns:a16="http://schemas.microsoft.com/office/drawing/2014/main" id="{2F9DD9AB-0B88-4DD5-BC8F-24D4C936D94F}"/>
+                <a16:creationId xmlns:a16="http://schemas.microsoft.com/office/drawing/2014/main" id="{C653AEF0-5FF3-4AD6-929B-FC3A8019283A}"/>
               </a:ext>
             </a:extLst>
           </p:cNvPr>
@@ -2145,7 +2145,7 @@
           <p:cNvPr id="4" name="Title">
             <a:extLst xmlns:a="http://schemas.openxmlformats.org/drawingml/2006/main">
               <a:ext uri="{FF2B5EF4-FFF2-40B4-BE49-F238E27FC236}">
-                <a16:creationId xmlns:a16="http://schemas.microsoft.com/office/drawing/2014/main" id="{E90D19EA-A2E9-4A53-92EB-3E5F18720338}"/>
+                <a16:creationId xmlns:a16="http://schemas.microsoft.com/office/drawing/2014/main" id="{4A0AE441-CD30-4D29-B755-3A89C62DF030}"/>
               </a:ext>
             </a:extLst>
           </p:cNvPr>
@@ -2302,7 +2302,7 @@
           <p:cNvPr id="2" name="Left column">
             <a:extLst xmlns:a="http://schemas.openxmlformats.org/drawingml/2006/main">
               <a:ext uri="{FF2B5EF4-FFF2-40B4-BE49-F238E27FC236}">
-                <a16:creationId xmlns:a16="http://schemas.microsoft.com/office/drawing/2014/main" id="{F46205A4-FF1E-47CE-8FAF-CF4B44B60AE4}"/>
+                <a16:creationId xmlns:a16="http://schemas.microsoft.com/office/drawing/2014/main" id="{533CDDB2-850C-4F5B-A10B-CA4CAB385157}"/>
               </a:ext>
             </a:extLst>
           </p:cNvPr>
@@ -2459,7 +2459,7 @@
           <p:cNvPr id="3" name="Right column">
             <a:extLst xmlns:a="http://schemas.openxmlformats.org/drawingml/2006/main">
               <a:ext uri="{FF2B5EF4-FFF2-40B4-BE49-F238E27FC236}">
-                <a16:creationId xmlns:a16="http://schemas.microsoft.com/office/drawing/2014/main" id="{1D483344-CD4C-4407-8256-30BFD7A76AFA}"/>
+                <a16:creationId xmlns:a16="http://schemas.microsoft.com/office/drawing/2014/main" id="{06644695-1C64-4D93-8395-00449228ED90}"/>
               </a:ext>
             </a:extLst>
           </p:cNvPr>
@@ -2633,7 +2633,7 @@
           <p:cNvPr id="3" name="Title">
             <a:extLst xmlns:a="http://schemas.openxmlformats.org/drawingml/2006/main">
               <a:ext uri="{FF2B5EF4-FFF2-40B4-BE49-F238E27FC236}">
-                <a16:creationId xmlns:a16="http://schemas.microsoft.com/office/drawing/2014/main" id="{C08478C6-760E-4815-B7E9-432764EB05C6}"/>
+                <a16:creationId xmlns:a16="http://schemas.microsoft.com/office/drawing/2014/main" id="{B571B83E-9CD0-46FE-ADBA-CD91B071E7A3}"/>
               </a:ext>
             </a:extLst>
           </p:cNvPr>
@@ -2790,7 +2790,7 @@
           <p:cNvPr id="2" name="Left column">
             <a:extLst xmlns:a="http://schemas.openxmlformats.org/drawingml/2006/main">
               <a:ext uri="{FF2B5EF4-FFF2-40B4-BE49-F238E27FC236}">
-                <a16:creationId xmlns:a16="http://schemas.microsoft.com/office/drawing/2014/main" id="{74B55994-0DC1-48F4-9B99-EBFB15E46F89}"/>
+                <a16:creationId xmlns:a16="http://schemas.microsoft.com/office/drawing/2014/main" id="{24180E5B-E7BC-45A7-B45B-702F5E63AEC2}"/>
               </a:ext>
             </a:extLst>
           </p:cNvPr>
@@ -2985,12 +2985,12 @@
   </p:cSld>
   <p:clrMap bg1="lt1" tx1="dk1" bg2="lt2" tx2="dk2" accent1="accent1" accent2="accent2" accent3="accent3" accent4="accent4" accent5="accent5" accent6="accent6" hlink="hlink" folHlink="folHlink"/>
   <p:sldLayoutIdLst>
-    <p:sldLayoutId xmlns:r="http://schemas.openxmlformats.org/officeDocument/2006/relationships" id="2147483649" r:id="Rb35fe27bfe0f4c40"/>
-    <p:sldLayoutId xmlns:r="http://schemas.openxmlformats.org/officeDocument/2006/relationships" id="2147483650" r:id="R91e17a1c0ef14303"/>
-    <p:sldLayoutId xmlns:r="http://schemas.openxmlformats.org/officeDocument/2006/relationships" id="2147483651" r:id="R6f810924ca7e4b53"/>
-    <p:sldLayoutId xmlns:r="http://schemas.openxmlformats.org/officeDocument/2006/relationships" id="2147483652" r:id="Rbf73477271af4cdb"/>
-    <p:sldLayoutId xmlns:r="http://schemas.openxmlformats.org/officeDocument/2006/relationships" id="2147483653" r:id="R5aeb1a1a18364707"/>
-    <p:sldLayoutId xmlns:r="http://schemas.openxmlformats.org/officeDocument/2006/relationships" id="2147483654" r:id="R9f9629fbacdc4101"/>
+    <p:sldLayoutId xmlns:r="http://schemas.openxmlformats.org/officeDocument/2006/relationships" id="2147483649" r:id="R3fa17c7d0d7c46be"/>
+    <p:sldLayoutId xmlns:r="http://schemas.openxmlformats.org/officeDocument/2006/relationships" id="2147483650" r:id="Rc2ff0a57940e449b"/>
+    <p:sldLayoutId xmlns:r="http://schemas.openxmlformats.org/officeDocument/2006/relationships" id="2147483651" r:id="R13aee509e9e54f82"/>
+    <p:sldLayoutId xmlns:r="http://schemas.openxmlformats.org/officeDocument/2006/relationships" id="2147483652" r:id="R78ed8bff075c47f8"/>
+    <p:sldLayoutId xmlns:r="http://schemas.openxmlformats.org/officeDocument/2006/relationships" id="2147483653" r:id="Rb138339bbcec412a"/>
+    <p:sldLayoutId xmlns:r="http://schemas.openxmlformats.org/officeDocument/2006/relationships" id="2147483654" r:id="Re44d7a85ea814e48"/>
   </p:sldLayoutIdLst>
   <p:txStyles>
     <p:titleStyle>
@@ -3541,7 +3541,7 @@
           <p:cNvPr id="5" name="">
             <a:extLst xmlns:a="http://schemas.openxmlformats.org/drawingml/2006/main">
               <a:ext uri="{FF2B5EF4-FFF2-40B4-BE49-F238E27FC236}">
-                <a16:creationId xmlns:a16="http://schemas.microsoft.com/office/drawing/2014/main" id="{412C013D-DF1B-4C6F-91AF-A4814AFABE36}"/>
+                <a16:creationId xmlns:a16="http://schemas.microsoft.com/office/drawing/2014/main" id="{B81B8CB0-96C1-483A-B646-42E67D1A4F00}"/>
               </a:ext>
             </a:extLst>
           </p:cNvPr>
@@ -3609,7 +3609,7 @@
           <p:cNvPr id="2" name="">
             <a:extLst xmlns:a="http://schemas.openxmlformats.org/drawingml/2006/main">
               <a:ext uri="{FF2B5EF4-FFF2-40B4-BE49-F238E27FC236}">
-                <a16:creationId xmlns:a16="http://schemas.microsoft.com/office/drawing/2014/main" id="{400A8B8B-42FB-4360-B037-6D4BDB7487BB}"/>
+                <a16:creationId xmlns:a16="http://schemas.microsoft.com/office/drawing/2014/main" id="{851FB30F-D839-489C-8260-379B8A8E436B}"/>
               </a:ext>
             </a:extLst>
           </p:cNvPr>
@@ -3677,7 +3677,7 @@
           <p:cNvPr id="3" name="">
             <a:extLst xmlns:a="http://schemas.openxmlformats.org/drawingml/2006/main">
               <a:ext uri="{FF2B5EF4-FFF2-40B4-BE49-F238E27FC236}">
-                <a16:creationId xmlns:a16="http://schemas.microsoft.com/office/drawing/2014/main" id="{E10CEB66-347F-4A97-AC2E-F078E0D5CC3A}"/>
+                <a16:creationId xmlns:a16="http://schemas.microsoft.com/office/drawing/2014/main" id="{200E6648-2BE6-47C7-B2CB-BF0346E51673}"/>
               </a:ext>
             </a:extLst>
           </p:cNvPr>
@@ -3745,7 +3745,7 @@
           <p:cNvPr id="4" name="">
             <a:extLst xmlns:a="http://schemas.openxmlformats.org/drawingml/2006/main">
               <a:ext uri="{FF2B5EF4-FFF2-40B4-BE49-F238E27FC236}">
-                <a16:creationId xmlns:a16="http://schemas.microsoft.com/office/drawing/2014/main" id="{310B8FD5-9201-427B-8BFB-2339D098AA3D}"/>
+                <a16:creationId xmlns:a16="http://schemas.microsoft.com/office/drawing/2014/main" id="{162BB909-7922-48C8-BA9F-F9A9961FA3FF}"/>
               </a:ext>
             </a:extLst>
           </p:cNvPr>
@@ -3834,7 +3834,7 @@
     </p:spTree>
     <p:extLst>
       <p:ext uri="{BB962C8B-B14F-4D97-AF65-F5344CB8AC3E}">
-        <p14:creationId xmlns:p14="http://schemas.microsoft.com/office/powerpoint/2010/main" val="357586503"/>
+        <p14:creationId xmlns:p14="http://schemas.microsoft.com/office/powerpoint/2010/main" val="1001809950"/>
       </p:ext>
     </p:extLst>
   </p:cSld>
@@ -3865,7 +3865,7 @@
           <p:cNvPr id="7" name="">
             <a:extLst xmlns:a="http://schemas.openxmlformats.org/drawingml/2006/main">
               <a:ext uri="{FF2B5EF4-FFF2-40B4-BE49-F238E27FC236}">
-                <a16:creationId xmlns:a16="http://schemas.microsoft.com/office/drawing/2014/main" id="{137873FE-A133-4498-9C0A-CEE760D4A8B3}"/>
+                <a16:creationId xmlns:a16="http://schemas.microsoft.com/office/drawing/2014/main" id="{D67E9636-F2AC-4BD0-9F3E-E0150F192657}"/>
               </a:ext>
             </a:extLst>
           </p:cNvPr>
@@ -3933,7 +3933,7 @@
           <p:cNvPr id="2" name="">
             <a:extLst xmlns:a="http://schemas.openxmlformats.org/drawingml/2006/main">
               <a:ext uri="{FF2B5EF4-FFF2-40B4-BE49-F238E27FC236}">
-                <a16:creationId xmlns:a16="http://schemas.microsoft.com/office/drawing/2014/main" id="{3B8C83EC-B2EC-4E05-9693-12A67F49DBF1}"/>
+                <a16:creationId xmlns:a16="http://schemas.microsoft.com/office/drawing/2014/main" id="{440EC79B-8F06-4C04-99EE-2EC2BC6CADDE}"/>
               </a:ext>
             </a:extLst>
           </p:cNvPr>
@@ -4001,7 +4001,7 @@
           <p:cNvPr id="3" name="">
             <a:extLst xmlns:a="http://schemas.openxmlformats.org/drawingml/2006/main">
               <a:ext uri="{FF2B5EF4-FFF2-40B4-BE49-F238E27FC236}">
-                <a16:creationId xmlns:a16="http://schemas.microsoft.com/office/drawing/2014/main" id="{98FE8FE0-37ED-489E-B736-74B432E1749D}"/>
+                <a16:creationId xmlns:a16="http://schemas.microsoft.com/office/drawing/2014/main" id="{21FBA692-33DC-4A44-AD98-3E80A7BB355B}"/>
               </a:ext>
             </a:extLst>
           </p:cNvPr>
@@ -4069,7 +4069,7 @@
           <p:cNvPr id="4" name="">
             <a:extLst xmlns:a="http://schemas.openxmlformats.org/drawingml/2006/main">
               <a:ext uri="{FF2B5EF4-FFF2-40B4-BE49-F238E27FC236}">
-                <a16:creationId xmlns:a16="http://schemas.microsoft.com/office/drawing/2014/main" id="{3139990C-4C15-430B-8B9F-762F7C58B1A2}"/>
+                <a16:creationId xmlns:a16="http://schemas.microsoft.com/office/drawing/2014/main" id="{399F45F9-CCF4-4ED2-81EB-70BB6208254B}"/>
               </a:ext>
             </a:extLst>
           </p:cNvPr>
@@ -4137,7 +4137,7 @@
           <p:cNvPr id="5" name="">
             <a:extLst xmlns:a="http://schemas.openxmlformats.org/drawingml/2006/main">
               <a:ext uri="{FF2B5EF4-FFF2-40B4-BE49-F238E27FC236}">
-                <a16:creationId xmlns:a16="http://schemas.microsoft.com/office/drawing/2014/main" id="{8F1D45D5-9800-4EB6-8F43-8E419FD2583A}"/>
+                <a16:creationId xmlns:a16="http://schemas.microsoft.com/office/drawing/2014/main" id="{4743577D-F44B-4817-B48A-B28DBE0D793A}"/>
               </a:ext>
             </a:extLst>
           </p:cNvPr>
@@ -4205,7 +4205,7 @@
           <p:cNvPr id="6" name="">
             <a:extLst xmlns:a="http://schemas.openxmlformats.org/drawingml/2006/main">
               <a:ext uri="{FF2B5EF4-FFF2-40B4-BE49-F238E27FC236}">
-                <a16:creationId xmlns:a16="http://schemas.microsoft.com/office/drawing/2014/main" id="{B6ABCF37-5409-4C0A-9F68-68894FB0CD5D}"/>
+                <a16:creationId xmlns:a16="http://schemas.microsoft.com/office/drawing/2014/main" id="{81487EC7-34F8-4804-85B7-A49B335857E6}"/>
               </a:ext>
             </a:extLst>
           </p:cNvPr>
@@ -4271,7 +4271,7 @@
     </p:spTree>
     <p:extLst>
       <p:ext uri="{BB962C8B-B14F-4D97-AF65-F5344CB8AC3E}">
-        <p14:creationId xmlns:p14="http://schemas.microsoft.com/office/powerpoint/2010/main" val="1638239941"/>
+        <p14:creationId xmlns:p14="http://schemas.microsoft.com/office/powerpoint/2010/main" val="1795058130"/>
       </p:ext>
     </p:extLst>
   </p:cSld>
@@ -4302,7 +4302,7 @@
           <p:cNvPr id="7" name="">
             <a:extLst xmlns:a="http://schemas.openxmlformats.org/drawingml/2006/main">
               <a:ext uri="{FF2B5EF4-FFF2-40B4-BE49-F238E27FC236}">
-                <a16:creationId xmlns:a16="http://schemas.microsoft.com/office/drawing/2014/main" id="{C7D64578-0792-4BB6-B851-4C62BBB0FB5F}"/>
+                <a16:creationId xmlns:a16="http://schemas.microsoft.com/office/drawing/2014/main" id="{5A747635-3820-4B41-AE3C-F4FDCC9EC263}"/>
               </a:ext>
             </a:extLst>
           </p:cNvPr>
@@ -4370,7 +4370,7 @@
           <p:cNvPr id="2" name="">
             <a:extLst xmlns:a="http://schemas.openxmlformats.org/drawingml/2006/main">
               <a:ext uri="{FF2B5EF4-FFF2-40B4-BE49-F238E27FC236}">
-                <a16:creationId xmlns:a16="http://schemas.microsoft.com/office/drawing/2014/main" id="{4FDAEC7D-4F84-4EFA-9474-0A3078985D97}"/>
+                <a16:creationId xmlns:a16="http://schemas.microsoft.com/office/drawing/2014/main" id="{F3584560-E6A3-44AF-B048-54151976D305}"/>
               </a:ext>
             </a:extLst>
           </p:cNvPr>
@@ -4438,7 +4438,7 @@
           <p:cNvPr id="3" name="">
             <a:extLst xmlns:a="http://schemas.openxmlformats.org/drawingml/2006/main">
               <a:ext uri="{FF2B5EF4-FFF2-40B4-BE49-F238E27FC236}">
-                <a16:creationId xmlns:a16="http://schemas.microsoft.com/office/drawing/2014/main" id="{0E4A4F59-FB88-4D0F-AFBA-875E934784FC}"/>
+                <a16:creationId xmlns:a16="http://schemas.microsoft.com/office/drawing/2014/main" id="{EFC4B7F2-83AA-42F9-80E1-0EA435150F48}"/>
               </a:ext>
             </a:extLst>
           </p:cNvPr>
@@ -4506,7 +4506,7 @@
           <p:cNvPr id="4" name="">
             <a:extLst xmlns:a="http://schemas.openxmlformats.org/drawingml/2006/main">
               <a:ext uri="{FF2B5EF4-FFF2-40B4-BE49-F238E27FC236}">
-                <a16:creationId xmlns:a16="http://schemas.microsoft.com/office/drawing/2014/main" id="{5432698B-CC06-44B6-A618-BA81CC024FD3}"/>
+                <a16:creationId xmlns:a16="http://schemas.microsoft.com/office/drawing/2014/main" id="{A746D447-B390-4416-AA4C-54D45EDCA5A8}"/>
               </a:ext>
             </a:extLst>
           </p:cNvPr>
@@ -4574,7 +4574,7 @@
           <p:cNvPr id="5" name="">
             <a:extLst xmlns:a="http://schemas.openxmlformats.org/drawingml/2006/main">
               <a:ext uri="{FF2B5EF4-FFF2-40B4-BE49-F238E27FC236}">
-                <a16:creationId xmlns:a16="http://schemas.microsoft.com/office/drawing/2014/main" id="{B218FD3B-A899-4511-AFD8-C87C063705C6}"/>
+                <a16:creationId xmlns:a16="http://schemas.microsoft.com/office/drawing/2014/main" id="{A564B131-FCAA-4687-960F-56F79C4B1B7B}"/>
               </a:ext>
             </a:extLst>
           </p:cNvPr>
@@ -4642,7 +4642,7 @@
           <p:cNvPr id="6" name="">
             <a:extLst xmlns:a="http://schemas.openxmlformats.org/drawingml/2006/main">
               <a:ext uri="{FF2B5EF4-FFF2-40B4-BE49-F238E27FC236}">
-                <a16:creationId xmlns:a16="http://schemas.microsoft.com/office/drawing/2014/main" id="{0801C052-1BEF-4C96-A6DD-AF2FF6487F20}"/>
+                <a16:creationId xmlns:a16="http://schemas.microsoft.com/office/drawing/2014/main" id="{BE369139-1015-4ED5-8FA3-6169F7887745}"/>
               </a:ext>
             </a:extLst>
           </p:cNvPr>
@@ -4708,7 +4708,7 @@
     </p:spTree>
     <p:extLst>
       <p:ext uri="{BB962C8B-B14F-4D97-AF65-F5344CB8AC3E}">
-        <p14:creationId xmlns:p14="http://schemas.microsoft.com/office/powerpoint/2010/main" val="1587632934"/>
+        <p14:creationId xmlns:p14="http://schemas.microsoft.com/office/powerpoint/2010/main" val="366744442"/>
       </p:ext>
     </p:extLst>
   </p:cSld>
@@ -4739,7 +4739,7 @@
           <p:cNvPr id="7" name="">
             <a:extLst xmlns:a="http://schemas.openxmlformats.org/drawingml/2006/main">
               <a:ext uri="{FF2B5EF4-FFF2-40B4-BE49-F238E27FC236}">
-                <a16:creationId xmlns:a16="http://schemas.microsoft.com/office/drawing/2014/main" id="{6877AF12-AF11-454C-9A04-624B16620D5D}"/>
+                <a16:creationId xmlns:a16="http://schemas.microsoft.com/office/drawing/2014/main" id="{2DDF2CAD-682E-486B-BC31-174AFFD5960D}"/>
               </a:ext>
             </a:extLst>
           </p:cNvPr>
@@ -4807,7 +4807,7 @@
           <p:cNvPr id="2" name="">
             <a:extLst xmlns:a="http://schemas.openxmlformats.org/drawingml/2006/main">
               <a:ext uri="{FF2B5EF4-FFF2-40B4-BE49-F238E27FC236}">
-                <a16:creationId xmlns:a16="http://schemas.microsoft.com/office/drawing/2014/main" id="{8E8809FE-8DBD-4660-82EC-25B9649FD618}"/>
+                <a16:creationId xmlns:a16="http://schemas.microsoft.com/office/drawing/2014/main" id="{0413ACA1-E025-4F59-8F1F-EBA0D377CDE3}"/>
               </a:ext>
             </a:extLst>
           </p:cNvPr>
@@ -4875,7 +4875,7 @@
           <p:cNvPr id="3" name="">
             <a:extLst xmlns:a="http://schemas.openxmlformats.org/drawingml/2006/main">
               <a:ext uri="{FF2B5EF4-FFF2-40B4-BE49-F238E27FC236}">
-                <a16:creationId xmlns:a16="http://schemas.microsoft.com/office/drawing/2014/main" id="{5B820F3A-D83A-4BEF-AAEB-D59B9351500A}"/>
+                <a16:creationId xmlns:a16="http://schemas.microsoft.com/office/drawing/2014/main" id="{3F8ABE0E-9399-4E73-9AAC-74E9BF03D003}"/>
               </a:ext>
             </a:extLst>
           </p:cNvPr>
@@ -4943,7 +4943,7 @@
           <p:cNvPr id="4" name="">
             <a:extLst xmlns:a="http://schemas.openxmlformats.org/drawingml/2006/main">
               <a:ext uri="{FF2B5EF4-FFF2-40B4-BE49-F238E27FC236}">
-                <a16:creationId xmlns:a16="http://schemas.microsoft.com/office/drawing/2014/main" id="{2828F0F3-BD5E-438C-9010-5F77CC3E9378}"/>
+                <a16:creationId xmlns:a16="http://schemas.microsoft.com/office/drawing/2014/main" id="{13141F30-4160-4AA8-9DAD-E3E49FBFC1CA}"/>
               </a:ext>
             </a:extLst>
           </p:cNvPr>
@@ -5011,7 +5011,7 @@
           <p:cNvPr id="5" name="">
             <a:extLst xmlns:a="http://schemas.openxmlformats.org/drawingml/2006/main">
               <a:ext uri="{FF2B5EF4-FFF2-40B4-BE49-F238E27FC236}">
-                <a16:creationId xmlns:a16="http://schemas.microsoft.com/office/drawing/2014/main" id="{90514297-DA54-4E63-9077-61D9CD0D595D}"/>
+                <a16:creationId xmlns:a16="http://schemas.microsoft.com/office/drawing/2014/main" id="{04386AE1-3826-41FF-9173-1D38F42BBDCA}"/>
               </a:ext>
             </a:extLst>
           </p:cNvPr>
@@ -5079,7 +5079,7 @@
           <p:cNvPr id="6" name="">
             <a:extLst xmlns:a="http://schemas.openxmlformats.org/drawingml/2006/main">
               <a:ext uri="{FF2B5EF4-FFF2-40B4-BE49-F238E27FC236}">
-                <a16:creationId xmlns:a16="http://schemas.microsoft.com/office/drawing/2014/main" id="{9B96FE67-0D82-442C-BD2B-BE419F895376}"/>
+                <a16:creationId xmlns:a16="http://schemas.microsoft.com/office/drawing/2014/main" id="{18D6C767-7633-4BDE-9BD9-01D17AAC0550}"/>
               </a:ext>
             </a:extLst>
           </p:cNvPr>
@@ -5145,7 +5145,7 @@
     </p:spTree>
     <p:extLst>
       <p:ext uri="{BB962C8B-B14F-4D97-AF65-F5344CB8AC3E}">
-        <p14:creationId xmlns:p14="http://schemas.microsoft.com/office/powerpoint/2010/main" val="772593164"/>
+        <p14:creationId xmlns:p14="http://schemas.microsoft.com/office/powerpoint/2010/main" val="1091307841"/>
       </p:ext>
     </p:extLst>
   </p:cSld>
@@ -5176,7 +5176,7 @@
           <p:cNvPr id="13" name="">
             <a:extLst xmlns:a="http://schemas.openxmlformats.org/drawingml/2006/main">
               <a:ext uri="{FF2B5EF4-FFF2-40B4-BE49-F238E27FC236}">
-                <a16:creationId xmlns:a16="http://schemas.microsoft.com/office/drawing/2014/main" id="{9F2F7289-2B04-489D-8036-DB7BC47ED857}"/>
+                <a16:creationId xmlns:a16="http://schemas.microsoft.com/office/drawing/2014/main" id="{461AE940-471B-47EB-9717-C4ACC8A34785}"/>
               </a:ext>
             </a:extLst>
           </p:cNvPr>
@@ -5244,7 +5244,7 @@
           <p:cNvPr id="2" name="">
             <a:extLst xmlns:a="http://schemas.openxmlformats.org/drawingml/2006/main">
               <a:ext uri="{FF2B5EF4-FFF2-40B4-BE49-F238E27FC236}">
-                <a16:creationId xmlns:a16="http://schemas.microsoft.com/office/drawing/2014/main" id="{66C44C81-2DF3-440E-B675-FC314CFF42E1}"/>
+                <a16:creationId xmlns:a16="http://schemas.microsoft.com/office/drawing/2014/main" id="{308D03F7-C3F7-46CA-87BF-F4EB14D4D762}"/>
               </a:ext>
             </a:extLst>
           </p:cNvPr>
@@ -5312,7 +5312,7 @@
           <p:cNvPr id="3" name="">
             <a:extLst xmlns:a="http://schemas.openxmlformats.org/drawingml/2006/main">
               <a:ext uri="{FF2B5EF4-FFF2-40B4-BE49-F238E27FC236}">
-                <a16:creationId xmlns:a16="http://schemas.microsoft.com/office/drawing/2014/main" id="{F57832DE-1BEE-4278-A9EC-908DB168B24D}"/>
+                <a16:creationId xmlns:a16="http://schemas.microsoft.com/office/drawing/2014/main" id="{FC0084F3-4D64-429F-A0DE-F085B4EE8055}"/>
               </a:ext>
             </a:extLst>
           </p:cNvPr>
@@ -5380,7 +5380,7 @@
           <p:cNvPr id="4" name="">
             <a:extLst xmlns:a="http://schemas.openxmlformats.org/drawingml/2006/main">
               <a:ext uri="{FF2B5EF4-FFF2-40B4-BE49-F238E27FC236}">
-                <a16:creationId xmlns:a16="http://schemas.microsoft.com/office/drawing/2014/main" id="{8AAD89F2-1768-4BBB-B68F-63C35155F56B}"/>
+                <a16:creationId xmlns:a16="http://schemas.microsoft.com/office/drawing/2014/main" id="{E59015D1-7DE0-4004-A255-8CE98DF89A1F}"/>
               </a:ext>
             </a:extLst>
           </p:cNvPr>
@@ -5448,7 +5448,7 @@
           <p:cNvPr id="5" name="">
             <a:extLst xmlns:a="http://schemas.openxmlformats.org/drawingml/2006/main">
               <a:ext uri="{FF2B5EF4-FFF2-40B4-BE49-F238E27FC236}">
-                <a16:creationId xmlns:a16="http://schemas.microsoft.com/office/drawing/2014/main" id="{DEBF5F7E-8E25-45B0-93CD-2565D33313C0}"/>
+                <a16:creationId xmlns:a16="http://schemas.microsoft.com/office/drawing/2014/main" id="{5E504004-2659-47B3-9271-6C641E5C84CE}"/>
               </a:ext>
             </a:extLst>
           </p:cNvPr>
@@ -5516,7 +5516,7 @@
           <p:cNvPr id="6" name="">
             <a:extLst xmlns:a="http://schemas.openxmlformats.org/drawingml/2006/main">
               <a:ext uri="{FF2B5EF4-FFF2-40B4-BE49-F238E27FC236}">
-                <a16:creationId xmlns:a16="http://schemas.microsoft.com/office/drawing/2014/main" id="{CC7C36A3-32FD-4F10-B0E6-2475584D8929}"/>
+                <a16:creationId xmlns:a16="http://schemas.microsoft.com/office/drawing/2014/main" id="{4C61513C-FAE9-4FD9-B58B-AC11C3C89A76}"/>
               </a:ext>
             </a:extLst>
           </p:cNvPr>
@@ -5584,7 +5584,7 @@
           <p:cNvPr id="7" name="">
             <a:extLst xmlns:a="http://schemas.openxmlformats.org/drawingml/2006/main">
               <a:ext uri="{FF2B5EF4-FFF2-40B4-BE49-F238E27FC236}">
-                <a16:creationId xmlns:a16="http://schemas.microsoft.com/office/drawing/2014/main" id="{7927B9BD-3323-47A6-8F8F-F5DE8880968B}"/>
+                <a16:creationId xmlns:a16="http://schemas.microsoft.com/office/drawing/2014/main" id="{60A2809D-A507-43E3-9F5D-CA1284224EB5}"/>
               </a:ext>
             </a:extLst>
           </p:cNvPr>
@@ -5652,7 +5652,7 @@
           <p:cNvPr id="8" name="">
             <a:extLst xmlns:a="http://schemas.openxmlformats.org/drawingml/2006/main">
               <a:ext uri="{FF2B5EF4-FFF2-40B4-BE49-F238E27FC236}">
-                <a16:creationId xmlns:a16="http://schemas.microsoft.com/office/drawing/2014/main" id="{043ABCA1-7190-41B1-B08F-450AD64CFE86}"/>
+                <a16:creationId xmlns:a16="http://schemas.microsoft.com/office/drawing/2014/main" id="{4571300D-8B0A-4F97-8D45-00D20210E4A9}"/>
               </a:ext>
             </a:extLst>
           </p:cNvPr>
@@ -5720,7 +5720,7 @@
           <p:cNvPr id="9" name="">
             <a:extLst xmlns:a="http://schemas.openxmlformats.org/drawingml/2006/main">
               <a:ext uri="{FF2B5EF4-FFF2-40B4-BE49-F238E27FC236}">
-                <a16:creationId xmlns:a16="http://schemas.microsoft.com/office/drawing/2014/main" id="{4FBEDB6E-F8E4-45E2-AB8B-FC7ABAB53769}"/>
+                <a16:creationId xmlns:a16="http://schemas.microsoft.com/office/drawing/2014/main" id="{1FF89758-A2E6-4152-9039-432544373647}"/>
               </a:ext>
             </a:extLst>
           </p:cNvPr>
@@ -5788,7 +5788,7 @@
           <p:cNvPr id="10" name="">
             <a:extLst xmlns:a="http://schemas.openxmlformats.org/drawingml/2006/main">
               <a:ext uri="{FF2B5EF4-FFF2-40B4-BE49-F238E27FC236}">
-                <a16:creationId xmlns:a16="http://schemas.microsoft.com/office/drawing/2014/main" id="{3A3EB745-0672-4C4E-8DBB-11A0FC99EB6A}"/>
+                <a16:creationId xmlns:a16="http://schemas.microsoft.com/office/drawing/2014/main" id="{2E9D252B-7F83-47C1-BBFA-B61380DA199E}"/>
               </a:ext>
             </a:extLst>
           </p:cNvPr>
@@ -5856,7 +5856,7 @@
           <p:cNvPr id="11" name="">
             <a:extLst xmlns:a="http://schemas.openxmlformats.org/drawingml/2006/main">
               <a:ext uri="{FF2B5EF4-FFF2-40B4-BE49-F238E27FC236}">
-                <a16:creationId xmlns:a16="http://schemas.microsoft.com/office/drawing/2014/main" id="{72C4A50B-B166-4C7D-B5D0-AC36096008E3}"/>
+                <a16:creationId xmlns:a16="http://schemas.microsoft.com/office/drawing/2014/main" id="{07120905-4CB2-4E71-8AE9-5AADC269E639}"/>
               </a:ext>
             </a:extLst>
           </p:cNvPr>
@@ -5924,7 +5924,7 @@
           <p:cNvPr id="12" name="">
             <a:extLst xmlns:a="http://schemas.openxmlformats.org/drawingml/2006/main">
               <a:ext uri="{FF2B5EF4-FFF2-40B4-BE49-F238E27FC236}">
-                <a16:creationId xmlns:a16="http://schemas.microsoft.com/office/drawing/2014/main" id="{773E1D97-1F6C-4A4A-8021-EA399A789565}"/>
+                <a16:creationId xmlns:a16="http://schemas.microsoft.com/office/drawing/2014/main" id="{E3409BDD-F9E7-43A5-B66E-878F6E5538D9}"/>
               </a:ext>
             </a:extLst>
           </p:cNvPr>
@@ -5990,7 +5990,7 @@
     </p:spTree>
     <p:extLst>
       <p:ext uri="{BB962C8B-B14F-4D97-AF65-F5344CB8AC3E}">
-        <p14:creationId xmlns:p14="http://schemas.microsoft.com/office/powerpoint/2010/main" val="1542979008"/>
+        <p14:creationId xmlns:p14="http://schemas.microsoft.com/office/powerpoint/2010/main" val="1290884971"/>
       </p:ext>
     </p:extLst>
   </p:cSld>
@@ -6021,7 +6021,7 @@
           <p:cNvPr id="15" name="">
             <a:extLst xmlns:a="http://schemas.openxmlformats.org/drawingml/2006/main">
               <a:ext uri="{FF2B5EF4-FFF2-40B4-BE49-F238E27FC236}">
-                <a16:creationId xmlns:a16="http://schemas.microsoft.com/office/drawing/2014/main" id="{BF931D5C-1229-4563-BE53-8B07031DC767}"/>
+                <a16:creationId xmlns:a16="http://schemas.microsoft.com/office/drawing/2014/main" id="{D5C5EE81-D289-4B35-8F4D-703D4FECCCD1}"/>
               </a:ext>
             </a:extLst>
           </p:cNvPr>
@@ -6052,7 +6052,7 @@
           <p:cNvPr id="14" name="">
             <a:extLst xmlns:a="http://schemas.openxmlformats.org/drawingml/2006/main">
               <a:ext uri="{FF2B5EF4-FFF2-40B4-BE49-F238E27FC236}">
-                <a16:creationId xmlns:a16="http://schemas.microsoft.com/office/drawing/2014/main" id="{C8FBE78A-F62F-4E37-B444-F223B3B1568E}"/>
+                <a16:creationId xmlns:a16="http://schemas.microsoft.com/office/drawing/2014/main" id="{ED619A1C-ED7C-4E3B-BAB5-08C003CE57B8}"/>
               </a:ext>
             </a:extLst>
           </p:cNvPr>
@@ -6086,7 +6086,7 @@
           <p:cNvPr id="13" name="">
             <a:extLst xmlns:a="http://schemas.openxmlformats.org/drawingml/2006/main">
               <a:ext uri="{FF2B5EF4-FFF2-40B4-BE49-F238E27FC236}">
-                <a16:creationId xmlns:a16="http://schemas.microsoft.com/office/drawing/2014/main" id="{2CDE1D8C-C662-4C8A-B20F-12838709D5AF}"/>
+                <a16:creationId xmlns:a16="http://schemas.microsoft.com/office/drawing/2014/main" id="{448EE9D7-1AAD-427F-8306-15DDD5A9C500}"/>
               </a:ext>
             </a:extLst>
           </p:cNvPr>
@@ -6117,7 +6117,7 @@
           <p:cNvPr id="12" name="">
             <a:extLst xmlns:a="http://schemas.openxmlformats.org/drawingml/2006/main">
               <a:ext uri="{FF2B5EF4-FFF2-40B4-BE49-F238E27FC236}">
-                <a16:creationId xmlns:a16="http://schemas.microsoft.com/office/drawing/2014/main" id="{AECF479C-9193-456D-8BA0-5830DB10E44A}"/>
+                <a16:creationId xmlns:a16="http://schemas.microsoft.com/office/drawing/2014/main" id="{BD499C12-1D25-4D61-8AA7-F6FE0FFB7986}"/>
               </a:ext>
             </a:extLst>
           </p:cNvPr>
@@ -6148,7 +6148,7 @@
           <p:cNvPr id="11" name="">
             <a:extLst xmlns:a="http://schemas.openxmlformats.org/drawingml/2006/main">
               <a:ext uri="{FF2B5EF4-FFF2-40B4-BE49-F238E27FC236}">
-                <a16:creationId xmlns:a16="http://schemas.microsoft.com/office/drawing/2014/main" id="{B7E5B9D0-A543-4AB8-B4B7-5D5FCB3719B6}"/>
+                <a16:creationId xmlns:a16="http://schemas.microsoft.com/office/drawing/2014/main" id="{FFC232CC-0D68-4237-9F17-1B8F63FD8027}"/>
               </a:ext>
             </a:extLst>
           </p:cNvPr>
@@ -6179,7 +6179,7 @@
           <p:cNvPr id="10" name="">
             <a:extLst xmlns:a="http://schemas.openxmlformats.org/drawingml/2006/main">
               <a:ext uri="{FF2B5EF4-FFF2-40B4-BE49-F238E27FC236}">
-                <a16:creationId xmlns:a16="http://schemas.microsoft.com/office/drawing/2014/main" id="{0F15F17E-8D69-46E6-971E-6D3C0B36C0A9}"/>
+                <a16:creationId xmlns:a16="http://schemas.microsoft.com/office/drawing/2014/main" id="{140E455B-F131-4D8C-A20A-4F0CCB6C1E35}"/>
               </a:ext>
             </a:extLst>
           </p:cNvPr>
@@ -6210,7 +6210,7 @@
           <p:cNvPr id="17" name="">
             <a:extLst xmlns:a="http://schemas.openxmlformats.org/drawingml/2006/main">
               <a:ext uri="{FF2B5EF4-FFF2-40B4-BE49-F238E27FC236}">
-                <a16:creationId xmlns:a16="http://schemas.microsoft.com/office/drawing/2014/main" id="{48355FB0-70BC-4C7A-A324-DFC2236B81E6}"/>
+                <a16:creationId xmlns:a16="http://schemas.microsoft.com/office/drawing/2014/main" id="{9E3C94D5-95E2-4840-94E5-4F7EAD0950AE}"/>
               </a:ext>
             </a:extLst>
           </p:cNvPr>
@@ -6278,7 +6278,7 @@
           <p:cNvPr id="2" name="">
             <a:extLst xmlns:a="http://schemas.openxmlformats.org/drawingml/2006/main">
               <a:ext uri="{FF2B5EF4-FFF2-40B4-BE49-F238E27FC236}">
-                <a16:creationId xmlns:a16="http://schemas.microsoft.com/office/drawing/2014/main" id="{AAB34C8A-919F-498F-8E4F-E8921A6121C7}"/>
+                <a16:creationId xmlns:a16="http://schemas.microsoft.com/office/drawing/2014/main" id="{B5D63446-CDAA-4816-B40B-0442FF236623}"/>
               </a:ext>
             </a:extLst>
           </p:cNvPr>
@@ -6346,7 +6346,7 @@
           <p:cNvPr id="3" name="">
             <a:extLst xmlns:a="http://schemas.openxmlformats.org/drawingml/2006/main">
               <a:ext uri="{FF2B5EF4-FFF2-40B4-BE49-F238E27FC236}">
-                <a16:creationId xmlns:a16="http://schemas.microsoft.com/office/drawing/2014/main" id="{F451576F-71C1-48EE-BCD3-BF671D7D0094}"/>
+                <a16:creationId xmlns:a16="http://schemas.microsoft.com/office/drawing/2014/main" id="{320C033C-8416-4FA5-871A-608486DBE97C}"/>
               </a:ext>
             </a:extLst>
           </p:cNvPr>
@@ -6414,7 +6414,7 @@
           <p:cNvPr id="4" name="">
             <a:extLst xmlns:a="http://schemas.openxmlformats.org/drawingml/2006/main">
               <a:ext uri="{FF2B5EF4-FFF2-40B4-BE49-F238E27FC236}">
-                <a16:creationId xmlns:a16="http://schemas.microsoft.com/office/drawing/2014/main" id="{DACF629E-DE6A-4555-9DB8-9D6C31B18B9A}"/>
+                <a16:creationId xmlns:a16="http://schemas.microsoft.com/office/drawing/2014/main" id="{3EC9BBCF-B671-41E4-8665-AE36B63A2504}"/>
               </a:ext>
             </a:extLst>
           </p:cNvPr>
@@ -6482,7 +6482,7 @@
           <p:cNvPr id="5" name="">
             <a:extLst xmlns:a="http://schemas.openxmlformats.org/drawingml/2006/main">
               <a:ext uri="{FF2B5EF4-FFF2-40B4-BE49-F238E27FC236}">
-                <a16:creationId xmlns:a16="http://schemas.microsoft.com/office/drawing/2014/main" id="{4DFF08FE-DCDF-41BB-996E-87074E5826C2}"/>
+                <a16:creationId xmlns:a16="http://schemas.microsoft.com/office/drawing/2014/main" id="{D50CE95F-C4E0-424F-A5B5-7A606E2C7AA7}"/>
               </a:ext>
             </a:extLst>
           </p:cNvPr>
@@ -6550,7 +6550,7 @@
           <p:cNvPr id="6" name="">
             <a:extLst xmlns:a="http://schemas.openxmlformats.org/drawingml/2006/main">
               <a:ext uri="{FF2B5EF4-FFF2-40B4-BE49-F238E27FC236}">
-                <a16:creationId xmlns:a16="http://schemas.microsoft.com/office/drawing/2014/main" id="{751B41CF-1C50-4E9E-BACB-1A9C174EEE98}"/>
+                <a16:creationId xmlns:a16="http://schemas.microsoft.com/office/drawing/2014/main" id="{34A5FFB9-5F6F-46FC-B82C-E868BE757B49}"/>
               </a:ext>
             </a:extLst>
           </p:cNvPr>
@@ -6618,7 +6618,7 @@
           <p:cNvPr id="7" name="">
             <a:extLst xmlns:a="http://schemas.openxmlformats.org/drawingml/2006/main">
               <a:ext uri="{FF2B5EF4-FFF2-40B4-BE49-F238E27FC236}">
-                <a16:creationId xmlns:a16="http://schemas.microsoft.com/office/drawing/2014/main" id="{9F270FB2-A13F-4104-8A50-8A40260C89E7}"/>
+                <a16:creationId xmlns:a16="http://schemas.microsoft.com/office/drawing/2014/main" id="{36E84AAE-4288-4E6F-9F6B-A3B531391C0D}"/>
               </a:ext>
             </a:extLst>
           </p:cNvPr>
@@ -6709,7 +6709,7 @@
           <p:cNvPr id="8" name="">
             <a:extLst xmlns:a="http://schemas.openxmlformats.org/drawingml/2006/main">
               <a:ext uri="{FF2B5EF4-FFF2-40B4-BE49-F238E27FC236}">
-                <a16:creationId xmlns:a16="http://schemas.microsoft.com/office/drawing/2014/main" id="{A310FC40-EA4E-4DDC-AE13-BEEABBB7053E}"/>
+                <a16:creationId xmlns:a16="http://schemas.microsoft.com/office/drawing/2014/main" id="{6086010A-540A-4116-B98F-4B9E74FFF378}"/>
               </a:ext>
             </a:extLst>
           </p:cNvPr>
@@ -6777,7 +6777,7 @@
           <p:cNvPr id="9" name="">
             <a:extLst xmlns:a="http://schemas.openxmlformats.org/drawingml/2006/main">
               <a:ext uri="{FF2B5EF4-FFF2-40B4-BE49-F238E27FC236}">
-                <a16:creationId xmlns:a16="http://schemas.microsoft.com/office/drawing/2014/main" id="{D2DE7A1A-FB6E-47EB-9C3E-914079782D2C}"/>
+                <a16:creationId xmlns:a16="http://schemas.microsoft.com/office/drawing/2014/main" id="{85C03298-4359-4C5E-B400-EBDCB45ADC6C}"/>
               </a:ext>
             </a:extLst>
           </p:cNvPr>
@@ -6845,7 +6845,7 @@
           <p:cNvPr id="16" name="">
             <a:extLst xmlns:a="http://schemas.openxmlformats.org/drawingml/2006/main">
               <a:ext uri="{FF2B5EF4-FFF2-40B4-BE49-F238E27FC236}">
-                <a16:creationId xmlns:a16="http://schemas.microsoft.com/office/drawing/2014/main" id="{FB12BCD0-5C71-44C9-AB23-4BB28841D6F2}"/>
+                <a16:creationId xmlns:a16="http://schemas.microsoft.com/office/drawing/2014/main" id="{CA4C1DB6-837B-48AB-88A2-CC148AAA89B9}"/>
               </a:ext>
             </a:extLst>
           </p:cNvPr>
@@ -6911,7 +6911,7 @@
     </p:spTree>
     <p:extLst>
       <p:ext uri="{BB962C8B-B14F-4D97-AF65-F5344CB8AC3E}">
-        <p14:creationId xmlns:p14="http://schemas.microsoft.com/office/powerpoint/2010/main" val="69472739"/>
+        <p14:creationId xmlns:p14="http://schemas.microsoft.com/office/powerpoint/2010/main" val="40679711"/>
       </p:ext>
     </p:extLst>
   </p:cSld>
@@ -6942,7 +6942,7 @@
           <p:cNvPr id="7" name="">
             <a:extLst xmlns:a="http://schemas.openxmlformats.org/drawingml/2006/main">
               <a:ext uri="{FF2B5EF4-FFF2-40B4-BE49-F238E27FC236}">
-                <a16:creationId xmlns:a16="http://schemas.microsoft.com/office/drawing/2014/main" id="{B8B89F11-F455-44AC-B6C1-520D24F4E4BC}"/>
+                <a16:creationId xmlns:a16="http://schemas.microsoft.com/office/drawing/2014/main" id="{CEA92B2E-2095-4148-99ED-576302A96250}"/>
               </a:ext>
             </a:extLst>
           </p:cNvPr>
@@ -7010,7 +7010,7 @@
           <p:cNvPr id="2" name="">
             <a:extLst xmlns:a="http://schemas.openxmlformats.org/drawingml/2006/main">
               <a:ext uri="{FF2B5EF4-FFF2-40B4-BE49-F238E27FC236}">
-                <a16:creationId xmlns:a16="http://schemas.microsoft.com/office/drawing/2014/main" id="{FF148FD9-40B5-4C0C-93AB-A28ECB327380}"/>
+                <a16:creationId xmlns:a16="http://schemas.microsoft.com/office/drawing/2014/main" id="{CF7CA7E5-758D-4F4E-858E-64A839E398FE}"/>
               </a:ext>
             </a:extLst>
           </p:cNvPr>
@@ -7078,7 +7078,7 @@
           <p:cNvPr id="3" name="">
             <a:extLst xmlns:a="http://schemas.openxmlformats.org/drawingml/2006/main">
               <a:ext uri="{FF2B5EF4-FFF2-40B4-BE49-F238E27FC236}">
-                <a16:creationId xmlns:a16="http://schemas.microsoft.com/office/drawing/2014/main" id="{23FEA303-CAF4-4A63-B99A-FDAF9FD0CFCF}"/>
+                <a16:creationId xmlns:a16="http://schemas.microsoft.com/office/drawing/2014/main" id="{E630E81A-E108-4F27-8203-E202F1841977}"/>
               </a:ext>
             </a:extLst>
           </p:cNvPr>
@@ -7146,7 +7146,7 @@
           <p:cNvPr id="4" name="">
             <a:extLst xmlns:a="http://schemas.openxmlformats.org/drawingml/2006/main">
               <a:ext uri="{FF2B5EF4-FFF2-40B4-BE49-F238E27FC236}">
-                <a16:creationId xmlns:a16="http://schemas.microsoft.com/office/drawing/2014/main" id="{B3056ED0-9846-45D4-8240-99D751F96452}"/>
+                <a16:creationId xmlns:a16="http://schemas.microsoft.com/office/drawing/2014/main" id="{32BF4D58-0AE6-4536-B1FB-B910690E699B}"/>
               </a:ext>
             </a:extLst>
           </p:cNvPr>
@@ -7214,7 +7214,7 @@
           <p:cNvPr id="5" name="">
             <a:extLst xmlns:a="http://schemas.openxmlformats.org/drawingml/2006/main">
               <a:ext uri="{FF2B5EF4-FFF2-40B4-BE49-F238E27FC236}">
-                <a16:creationId xmlns:a16="http://schemas.microsoft.com/office/drawing/2014/main" id="{9341208E-757A-46B3-A86C-1F521DF71036}"/>
+                <a16:creationId xmlns:a16="http://schemas.microsoft.com/office/drawing/2014/main" id="{383BB481-A49B-4495-B939-27D1A7A7F72B}"/>
               </a:ext>
             </a:extLst>
           </p:cNvPr>
@@ -7282,7 +7282,7 @@
           <p:cNvPr id="6" name="">
             <a:extLst xmlns:a="http://schemas.openxmlformats.org/drawingml/2006/main">
               <a:ext uri="{FF2B5EF4-FFF2-40B4-BE49-F238E27FC236}">
-                <a16:creationId xmlns:a16="http://schemas.microsoft.com/office/drawing/2014/main" id="{97949B3B-928F-4BD8-91D8-0E19F6D273CE}"/>
+                <a16:creationId xmlns:a16="http://schemas.microsoft.com/office/drawing/2014/main" id="{EE3EE5D7-B47E-4358-9C5A-04B3F5AB917F}"/>
               </a:ext>
             </a:extLst>
           </p:cNvPr>
@@ -7348,7 +7348,7 @@
     </p:spTree>
     <p:extLst>
       <p:ext uri="{BB962C8B-B14F-4D97-AF65-F5344CB8AC3E}">
-        <p14:creationId xmlns:p14="http://schemas.microsoft.com/office/powerpoint/2010/main" val="298922907"/>
+        <p14:creationId xmlns:p14="http://schemas.microsoft.com/office/powerpoint/2010/main" val="683072460"/>
       </p:ext>
     </p:extLst>
   </p:cSld>
@@ -7379,7 +7379,7 @@
           <p:cNvPr id="7" name="">
             <a:extLst xmlns:a="http://schemas.openxmlformats.org/drawingml/2006/main">
               <a:ext uri="{FF2B5EF4-FFF2-40B4-BE49-F238E27FC236}">
-                <a16:creationId xmlns:a16="http://schemas.microsoft.com/office/drawing/2014/main" id="{7F03D618-96EE-4E86-8F2A-584FE1372031}"/>
+                <a16:creationId xmlns:a16="http://schemas.microsoft.com/office/drawing/2014/main" id="{8DDA2DEE-4D5F-402A-AEB1-3BF93AD6F667}"/>
               </a:ext>
             </a:extLst>
           </p:cNvPr>
@@ -7447,7 +7447,7 @@
           <p:cNvPr id="2" name="">
             <a:extLst xmlns:a="http://schemas.openxmlformats.org/drawingml/2006/main">
               <a:ext uri="{FF2B5EF4-FFF2-40B4-BE49-F238E27FC236}">
-                <a16:creationId xmlns:a16="http://schemas.microsoft.com/office/drawing/2014/main" id="{8C44B16A-5A28-4160-B358-84F75BAFF568}"/>
+                <a16:creationId xmlns:a16="http://schemas.microsoft.com/office/drawing/2014/main" id="{B9B5F6F4-182A-45A2-98AA-76D8BDE57278}"/>
               </a:ext>
             </a:extLst>
           </p:cNvPr>
@@ -7515,7 +7515,7 @@
           <p:cNvPr id="3" name="">
             <a:extLst xmlns:a="http://schemas.openxmlformats.org/drawingml/2006/main">
               <a:ext uri="{FF2B5EF4-FFF2-40B4-BE49-F238E27FC236}">
-                <a16:creationId xmlns:a16="http://schemas.microsoft.com/office/drawing/2014/main" id="{38A6FCD3-7913-4D33-90A3-54788CE75C18}"/>
+                <a16:creationId xmlns:a16="http://schemas.microsoft.com/office/drawing/2014/main" id="{35D7575B-E549-4C7F-994B-D4F6A26833CE}"/>
               </a:ext>
             </a:extLst>
           </p:cNvPr>
@@ -7583,7 +7583,7 @@
           <p:cNvPr id="4" name="">
             <a:extLst xmlns:a="http://schemas.openxmlformats.org/drawingml/2006/main">
               <a:ext uri="{FF2B5EF4-FFF2-40B4-BE49-F238E27FC236}">
-                <a16:creationId xmlns:a16="http://schemas.microsoft.com/office/drawing/2014/main" id="{288A364D-3057-480E-A88B-1017187AE860}"/>
+                <a16:creationId xmlns:a16="http://schemas.microsoft.com/office/drawing/2014/main" id="{F64EA879-8DCF-4AA3-B7A4-D7D440205589}"/>
               </a:ext>
             </a:extLst>
           </p:cNvPr>
@@ -7651,7 +7651,7 @@
           <p:cNvPr id="5" name="">
             <a:extLst xmlns:a="http://schemas.openxmlformats.org/drawingml/2006/main">
               <a:ext uri="{FF2B5EF4-FFF2-40B4-BE49-F238E27FC236}">
-                <a16:creationId xmlns:a16="http://schemas.microsoft.com/office/drawing/2014/main" id="{CA48204A-D887-40A7-8288-3A13781FB66D}"/>
+                <a16:creationId xmlns:a16="http://schemas.microsoft.com/office/drawing/2014/main" id="{A5AED358-4C02-4555-A5B5-922D7074AB0C}"/>
               </a:ext>
             </a:extLst>
           </p:cNvPr>
@@ -7709,7 +7709,7 @@
                 <a:ea typeface="Arial"/>
                 <a:cs typeface="Arial"/>
               </a:rPr>
-              <a:t>EKS 1.35 and two t3.medium managed worker nodes.</a:t>
+              <a:t>EKS 1.35 and two managed worker nodes.</a:t>
             </a:r>
           </a:p>
         </p:txBody>
@@ -7719,7 +7719,7 @@
           <p:cNvPr id="6" name="">
             <a:extLst xmlns:a="http://schemas.openxmlformats.org/drawingml/2006/main">
               <a:ext uri="{FF2B5EF4-FFF2-40B4-BE49-F238E27FC236}">
-                <a16:creationId xmlns:a16="http://schemas.microsoft.com/office/drawing/2014/main" id="{79C918B2-29CF-423E-925C-A6599994279F}"/>
+                <a16:creationId xmlns:a16="http://schemas.microsoft.com/office/drawing/2014/main" id="{88D8ADDD-8434-47F0-B035-7D37F68635EC}"/>
               </a:ext>
             </a:extLst>
           </p:cNvPr>
@@ -7785,7 +7785,7 @@
     </p:spTree>
     <p:extLst>
       <p:ext uri="{BB962C8B-B14F-4D97-AF65-F5344CB8AC3E}">
-        <p14:creationId xmlns:p14="http://schemas.microsoft.com/office/powerpoint/2010/main" val="244186678"/>
+        <p14:creationId xmlns:p14="http://schemas.microsoft.com/office/powerpoint/2010/main" val="1465209594"/>
       </p:ext>
     </p:extLst>
   </p:cSld>
@@ -7816,7 +7816,7 @@
           <p:cNvPr id="7" name="">
             <a:extLst xmlns:a="http://schemas.openxmlformats.org/drawingml/2006/main">
               <a:ext uri="{FF2B5EF4-FFF2-40B4-BE49-F238E27FC236}">
-                <a16:creationId xmlns:a16="http://schemas.microsoft.com/office/drawing/2014/main" id="{F25222CE-854D-4AD5-88E5-C4FBEBB5441D}"/>
+                <a16:creationId xmlns:a16="http://schemas.microsoft.com/office/drawing/2014/main" id="{191A7C38-9373-4A6A-A8DC-011A9AC31668}"/>
               </a:ext>
             </a:extLst>
           </p:cNvPr>
@@ -7884,7 +7884,7 @@
           <p:cNvPr id="2" name="">
             <a:extLst xmlns:a="http://schemas.openxmlformats.org/drawingml/2006/main">
               <a:ext uri="{FF2B5EF4-FFF2-40B4-BE49-F238E27FC236}">
-                <a16:creationId xmlns:a16="http://schemas.microsoft.com/office/drawing/2014/main" id="{68534733-DA72-46F0-91DF-F5808828A34A}"/>
+                <a16:creationId xmlns:a16="http://schemas.microsoft.com/office/drawing/2014/main" id="{8BF4E968-88ED-45D4-96B8-CB55DA976B2D}"/>
               </a:ext>
             </a:extLst>
           </p:cNvPr>
@@ -7952,7 +7952,7 @@
           <p:cNvPr id="3" name="">
             <a:extLst xmlns:a="http://schemas.openxmlformats.org/drawingml/2006/main">
               <a:ext uri="{FF2B5EF4-FFF2-40B4-BE49-F238E27FC236}">
-                <a16:creationId xmlns:a16="http://schemas.microsoft.com/office/drawing/2014/main" id="{AF09E800-4354-41E8-9375-811FE27E0442}"/>
+                <a16:creationId xmlns:a16="http://schemas.microsoft.com/office/drawing/2014/main" id="{2CBE5AA5-7091-468D-9E12-D8597BAA329D}"/>
               </a:ext>
             </a:extLst>
           </p:cNvPr>
@@ -8020,7 +8020,7 @@
           <p:cNvPr id="4" name="">
             <a:extLst xmlns:a="http://schemas.openxmlformats.org/drawingml/2006/main">
               <a:ext uri="{FF2B5EF4-FFF2-40B4-BE49-F238E27FC236}">
-                <a16:creationId xmlns:a16="http://schemas.microsoft.com/office/drawing/2014/main" id="{5D3CC170-615D-46F8-A7CB-3F51BA688999}"/>
+                <a16:creationId xmlns:a16="http://schemas.microsoft.com/office/drawing/2014/main" id="{6CAF4A50-49A5-45C7-BA10-6FC0165F29C3}"/>
               </a:ext>
             </a:extLst>
           </p:cNvPr>
@@ -8088,7 +8088,7 @@
           <p:cNvPr id="5" name="">
             <a:extLst xmlns:a="http://schemas.openxmlformats.org/drawingml/2006/main">
               <a:ext uri="{FF2B5EF4-FFF2-40B4-BE49-F238E27FC236}">
-                <a16:creationId xmlns:a16="http://schemas.microsoft.com/office/drawing/2014/main" id="{A380DCAB-24AE-41A8-966E-E7CEBB29EC81}"/>
+                <a16:creationId xmlns:a16="http://schemas.microsoft.com/office/drawing/2014/main" id="{6EA970CA-D88C-4848-A3E0-01508E45B7DA}"/>
               </a:ext>
             </a:extLst>
           </p:cNvPr>
@@ -8156,7 +8156,7 @@
           <p:cNvPr id="6" name="">
             <a:extLst xmlns:a="http://schemas.openxmlformats.org/drawingml/2006/main">
               <a:ext uri="{FF2B5EF4-FFF2-40B4-BE49-F238E27FC236}">
-                <a16:creationId xmlns:a16="http://schemas.microsoft.com/office/drawing/2014/main" id="{8FE99F05-445E-438F-8812-D73EEC174423}"/>
+                <a16:creationId xmlns:a16="http://schemas.microsoft.com/office/drawing/2014/main" id="{63DD11F5-AD06-4942-8012-A5BC609D1157}"/>
               </a:ext>
             </a:extLst>
           </p:cNvPr>
@@ -8222,7 +8222,7 @@
     </p:spTree>
     <p:extLst>
       <p:ext uri="{BB962C8B-B14F-4D97-AF65-F5344CB8AC3E}">
-        <p14:creationId xmlns:p14="http://schemas.microsoft.com/office/powerpoint/2010/main" val="1773746924"/>
+        <p14:creationId xmlns:p14="http://schemas.microsoft.com/office/powerpoint/2010/main" val="239861731"/>
       </p:ext>
     </p:extLst>
   </p:cSld>
@@ -8253,7 +8253,7 @@
           <p:cNvPr id="8" name="">
             <a:extLst xmlns:a="http://schemas.openxmlformats.org/drawingml/2006/main">
               <a:ext uri="{FF2B5EF4-FFF2-40B4-BE49-F238E27FC236}">
-                <a16:creationId xmlns:a16="http://schemas.microsoft.com/office/drawing/2014/main" id="{AEBFA275-CDE4-407F-8482-03542BC798C8}"/>
+                <a16:creationId xmlns:a16="http://schemas.microsoft.com/office/drawing/2014/main" id="{B4727D57-21DD-4CE1-9F91-988B6291A8AB}"/>
               </a:ext>
             </a:extLst>
           </p:cNvPr>
@@ -8321,7 +8321,7 @@
           <p:cNvPr id="2" name="">
             <a:extLst xmlns:a="http://schemas.openxmlformats.org/drawingml/2006/main">
               <a:ext uri="{FF2B5EF4-FFF2-40B4-BE49-F238E27FC236}">
-                <a16:creationId xmlns:a16="http://schemas.microsoft.com/office/drawing/2014/main" id="{4898AE59-66F8-44DD-BD44-A10CF3C3CC53}"/>
+                <a16:creationId xmlns:a16="http://schemas.microsoft.com/office/drawing/2014/main" id="{4F12D2C5-54F3-4927-A033-9685F22478B5}"/>
               </a:ext>
             </a:extLst>
           </p:cNvPr>
@@ -8389,7 +8389,7 @@
           <p:cNvPr id="3" name="">
             <a:extLst xmlns:a="http://schemas.openxmlformats.org/drawingml/2006/main">
               <a:ext uri="{FF2B5EF4-FFF2-40B4-BE49-F238E27FC236}">
-                <a16:creationId xmlns:a16="http://schemas.microsoft.com/office/drawing/2014/main" id="{070A444D-711D-4D2F-BAF5-517187FD4CB5}"/>
+                <a16:creationId xmlns:a16="http://schemas.microsoft.com/office/drawing/2014/main" id="{CBBB1498-D4BE-41C4-A371-2C6CDA02580C}"/>
               </a:ext>
             </a:extLst>
           </p:cNvPr>
@@ -8457,7 +8457,7 @@
           <p:cNvPr id="4" name="">
             <a:extLst xmlns:a="http://schemas.openxmlformats.org/drawingml/2006/main">
               <a:ext uri="{FF2B5EF4-FFF2-40B4-BE49-F238E27FC236}">
-                <a16:creationId xmlns:a16="http://schemas.microsoft.com/office/drawing/2014/main" id="{1BD6B372-F5F4-47DD-8B9E-F7BC68691CC0}"/>
+                <a16:creationId xmlns:a16="http://schemas.microsoft.com/office/drawing/2014/main" id="{621FCDB3-EEC3-4080-B820-554B9AABC1A3}"/>
               </a:ext>
             </a:extLst>
           </p:cNvPr>
@@ -8525,7 +8525,7 @@
           <p:cNvPr id="5" name="">
             <a:extLst xmlns:a="http://schemas.openxmlformats.org/drawingml/2006/main">
               <a:ext uri="{FF2B5EF4-FFF2-40B4-BE49-F238E27FC236}">
-                <a16:creationId xmlns:a16="http://schemas.microsoft.com/office/drawing/2014/main" id="{D636D7B3-67CD-4E3D-B864-5DDFFCBFC800}"/>
+                <a16:creationId xmlns:a16="http://schemas.microsoft.com/office/drawing/2014/main" id="{72F44292-7AC7-4C58-B305-5C0360108F6C}"/>
               </a:ext>
             </a:extLst>
           </p:cNvPr>
@@ -8593,7 +8593,7 @@
           <p:cNvPr id="6" name="">
             <a:extLst xmlns:a="http://schemas.openxmlformats.org/drawingml/2006/main">
               <a:ext uri="{FF2B5EF4-FFF2-40B4-BE49-F238E27FC236}">
-                <a16:creationId xmlns:a16="http://schemas.microsoft.com/office/drawing/2014/main" id="{5934FAF1-0D8D-4220-9FCF-4CDAD07CCF83}"/>
+                <a16:creationId xmlns:a16="http://schemas.microsoft.com/office/drawing/2014/main" id="{381D14A0-152D-43E9-B201-61B2275BE18D}"/>
               </a:ext>
             </a:extLst>
           </p:cNvPr>
@@ -8661,7 +8661,7 @@
           <p:cNvPr id="7" name="">
             <a:extLst xmlns:a="http://schemas.openxmlformats.org/drawingml/2006/main">
               <a:ext uri="{FF2B5EF4-FFF2-40B4-BE49-F238E27FC236}">
-                <a16:creationId xmlns:a16="http://schemas.microsoft.com/office/drawing/2014/main" id="{2F5C7647-E697-4C3B-A5F2-D719D821D777}"/>
+                <a16:creationId xmlns:a16="http://schemas.microsoft.com/office/drawing/2014/main" id="{FD4F9319-3969-4F25-8E01-A73EE1D70A33}"/>
               </a:ext>
             </a:extLst>
           </p:cNvPr>
@@ -8727,7 +8727,7 @@
     </p:spTree>
     <p:extLst>
       <p:ext uri="{BB962C8B-B14F-4D97-AF65-F5344CB8AC3E}">
-        <p14:creationId xmlns:p14="http://schemas.microsoft.com/office/powerpoint/2010/main" val="790866063"/>
+        <p14:creationId xmlns:p14="http://schemas.microsoft.com/office/powerpoint/2010/main" val="1095620400"/>
       </p:ext>
     </p:extLst>
   </p:cSld>
@@ -8758,7 +8758,7 @@
           <p:cNvPr id="7" name="">
             <a:extLst xmlns:a="http://schemas.openxmlformats.org/drawingml/2006/main">
               <a:ext uri="{FF2B5EF4-FFF2-40B4-BE49-F238E27FC236}">
-                <a16:creationId xmlns:a16="http://schemas.microsoft.com/office/drawing/2014/main" id="{24B66E26-43CE-41E2-ACFE-4C36DA39A28E}"/>
+                <a16:creationId xmlns:a16="http://schemas.microsoft.com/office/drawing/2014/main" id="{C160D4F8-C6E9-4233-9167-026683DB794D}"/>
               </a:ext>
             </a:extLst>
           </p:cNvPr>
@@ -8826,7 +8826,7 @@
           <p:cNvPr id="2" name="">
             <a:extLst xmlns:a="http://schemas.openxmlformats.org/drawingml/2006/main">
               <a:ext uri="{FF2B5EF4-FFF2-40B4-BE49-F238E27FC236}">
-                <a16:creationId xmlns:a16="http://schemas.microsoft.com/office/drawing/2014/main" id="{920C31AD-35F8-4CF2-9C21-8E083AA0C040}"/>
+                <a16:creationId xmlns:a16="http://schemas.microsoft.com/office/drawing/2014/main" id="{2754FCB8-3A7C-4C07-9B66-3F63E84AE020}"/>
               </a:ext>
             </a:extLst>
           </p:cNvPr>
@@ -8894,7 +8894,7 @@
           <p:cNvPr id="3" name="">
             <a:extLst xmlns:a="http://schemas.openxmlformats.org/drawingml/2006/main">
               <a:ext uri="{FF2B5EF4-FFF2-40B4-BE49-F238E27FC236}">
-                <a16:creationId xmlns:a16="http://schemas.microsoft.com/office/drawing/2014/main" id="{B4AA7907-1000-4BE4-B0E3-A4098B4060ED}"/>
+                <a16:creationId xmlns:a16="http://schemas.microsoft.com/office/drawing/2014/main" id="{18FFE8C8-ED73-45C3-ADD0-CC1DFE98FB34}"/>
               </a:ext>
             </a:extLst>
           </p:cNvPr>
@@ -8962,7 +8962,7 @@
           <p:cNvPr id="4" name="">
             <a:extLst xmlns:a="http://schemas.openxmlformats.org/drawingml/2006/main">
               <a:ext uri="{FF2B5EF4-FFF2-40B4-BE49-F238E27FC236}">
-                <a16:creationId xmlns:a16="http://schemas.microsoft.com/office/drawing/2014/main" id="{33EBC4AC-23F9-4500-8F52-F522D989493E}"/>
+                <a16:creationId xmlns:a16="http://schemas.microsoft.com/office/drawing/2014/main" id="{F6614BEE-F54A-476C-AA56-AEF40887A839}"/>
               </a:ext>
             </a:extLst>
           </p:cNvPr>
@@ -9030,7 +9030,7 @@
           <p:cNvPr id="5" name="">
             <a:extLst xmlns:a="http://schemas.openxmlformats.org/drawingml/2006/main">
               <a:ext uri="{FF2B5EF4-FFF2-40B4-BE49-F238E27FC236}">
-                <a16:creationId xmlns:a16="http://schemas.microsoft.com/office/drawing/2014/main" id="{8BC437B4-81DA-45A7-BCA3-D792D897D3DF}"/>
+                <a16:creationId xmlns:a16="http://schemas.microsoft.com/office/drawing/2014/main" id="{9FB09DAE-566C-4ED9-B062-450F8B71587E}"/>
               </a:ext>
             </a:extLst>
           </p:cNvPr>
@@ -9098,7 +9098,7 @@
           <p:cNvPr id="6" name="">
             <a:extLst xmlns:a="http://schemas.openxmlformats.org/drawingml/2006/main">
               <a:ext uri="{FF2B5EF4-FFF2-40B4-BE49-F238E27FC236}">
-                <a16:creationId xmlns:a16="http://schemas.microsoft.com/office/drawing/2014/main" id="{17EDAEC0-A905-4022-8400-B46C46B8BD60}"/>
+                <a16:creationId xmlns:a16="http://schemas.microsoft.com/office/drawing/2014/main" id="{D1A08D58-027B-40A7-8325-495D7E3C6568}"/>
               </a:ext>
             </a:extLst>
           </p:cNvPr>
@@ -9164,7 +9164,7 @@
     </p:spTree>
     <p:extLst>
       <p:ext uri="{BB962C8B-B14F-4D97-AF65-F5344CB8AC3E}">
-        <p14:creationId xmlns:p14="http://schemas.microsoft.com/office/powerpoint/2010/main" val="746294741"/>
+        <p14:creationId xmlns:p14="http://schemas.microsoft.com/office/powerpoint/2010/main" val="1108744729"/>
       </p:ext>
     </p:extLst>
   </p:cSld>

</xml_diff>